<commit_message>
Add architecture docs palette and slide images
</commit_message>
<xml_diff>
--- a/Slide/LSH26-T033-P01.pptx
+++ b/Slide/LSH26-T033-P01.pptx
@@ -3455,9 +3455,33 @@
           </a:prstGeom>
         </p:spPr>
       </p:pic>
-      <p:sp>
-        <p:nvSpPr>
-          <p:cNvPr id="5" name="TextBox 4"/>
+      <p:pic>
+        <p:nvPicPr>
+          <p:cNvPr id="5" name="Picture 4" descr="mark-cursor.png"/>
+          <p:cNvPicPr>
+            <a:picLocks noChangeAspect="1"/>
+          </p:cNvPicPr>
+          <p:nvPr/>
+        </p:nvPicPr>
+        <p:blipFill>
+          <a:blip r:embed="rId3"/>
+          <a:stretch>
+            <a:fillRect/>
+          </a:stretch>
+        </p:blipFill>
+        <p:spPr>
+          <a:xfrm>
+            <a:off x="15224760" y="8366760"/>
+            <a:ext cx="1737360" cy="1737360"/>
+          </a:xfrm>
+          <a:prstGeom prst="rect">
+            <a:avLst/>
+          </a:prstGeom>
+        </p:spPr>
+      </p:pic>
+      <p:sp>
+        <p:nvSpPr>
+          <p:cNvPr id="6" name="TextBox 5"/>
           <p:cNvSpPr txBox="1"/>
           <p:nvPr/>
         </p:nvSpPr>
@@ -3499,7 +3523,7 @@
       </p:sp>
       <p:sp>
         <p:nvSpPr>
-          <p:cNvPr id="6" name="TextBox 5"/>
+          <p:cNvPr id="7" name="TextBox 6"/>
           <p:cNvSpPr txBox="1"/>
           <p:nvPr/>
         </p:nvSpPr>
@@ -4051,7 +4075,7 @@
         <p:spPr>
           <a:xfrm>
             <a:off x="10927080" y="3108960"/>
-            <a:ext cx="3291840" cy="2286000"/>
+            <a:ext cx="3291840" cy="2743200"/>
           </a:xfrm>
           <a:prstGeom prst="roundRect">
             <a:avLst>
@@ -4136,7 +4160,7 @@
         </p:nvSpPr>
         <p:spPr>
           <a:xfrm>
-            <a:off x="11311128" y="4526280"/>
+            <a:off x="11311128" y="4983480"/>
             <a:ext cx="2523744" cy="731520"/>
           </a:xfrm>
           <a:prstGeom prst="rect">
@@ -4179,7 +4203,7 @@
         <p:spPr>
           <a:xfrm>
             <a:off x="14538960" y="3108960"/>
-            <a:ext cx="3291840" cy="2286000"/>
+            <a:ext cx="3291840" cy="2743200"/>
           </a:xfrm>
           <a:prstGeom prst="roundRect">
             <a:avLst>
@@ -4266,7 +4290,7 @@
         </p:nvSpPr>
         <p:spPr>
           <a:xfrm>
-            <a:off x="14923008" y="4526280"/>
+            <a:off x="14923008" y="4983480"/>
             <a:ext cx="2523744" cy="731520"/>
           </a:xfrm>
           <a:prstGeom prst="rect">
@@ -4308,8 +4332,8 @@
         </p:nvSpPr>
         <p:spPr>
           <a:xfrm>
-            <a:off x="10927080" y="5623560"/>
-            <a:ext cx="6903720" cy="2011680"/>
+            <a:off x="10927080" y="6126480"/>
+            <a:ext cx="6903720" cy="2377440"/>
           </a:xfrm>
           <a:prstGeom prst="roundRect">
             <a:avLst>
@@ -4354,7 +4378,7 @@
         </p:nvSpPr>
         <p:spPr>
           <a:xfrm>
-            <a:off x="11311128" y="5971032"/>
+            <a:off x="11311128" y="6473952"/>
             <a:ext cx="6135624" cy="914400"/>
           </a:xfrm>
           <a:prstGeom prst="rect">
@@ -4396,7 +4420,7 @@
         </p:nvSpPr>
         <p:spPr>
           <a:xfrm>
-            <a:off x="11311128" y="6766560"/>
+            <a:off x="11311128" y="7635240"/>
             <a:ext cx="6135624" cy="731520"/>
           </a:xfrm>
           <a:prstGeom prst="rect">
@@ -4590,8 +4614,8 @@
         </p:nvSpPr>
         <p:spPr>
           <a:xfrm>
-            <a:off x="1234440" y="3154680"/>
-            <a:ext cx="3783330" cy="4023360"/>
+            <a:off x="1234440" y="3108960"/>
+            <a:ext cx="3783330" cy="5394960"/>
           </a:xfrm>
           <a:prstGeom prst="roundRect">
             <a:avLst>
@@ -4628,16 +4652,142 @@
           <a:p/>
         </p:txBody>
       </p:sp>
-      <p:sp>
-        <p:nvSpPr>
-          <p:cNvPr id="6" name="Rounded Rectangle 5"/>
+      <p:pic>
+        <p:nvPicPr>
+          <p:cNvPr id="6" name="Picture 5" descr="badge-1.png"/>
+          <p:cNvPicPr>
+            <a:picLocks noChangeAspect="1"/>
+          </p:cNvPicPr>
+          <p:nvPr/>
+        </p:nvPicPr>
+        <p:blipFill>
+          <a:blip r:embed="rId2"/>
+          <a:stretch>
+            <a:fillRect/>
+          </a:stretch>
+        </p:blipFill>
+        <p:spPr>
+          <a:xfrm>
+            <a:off x="1618488" y="3493008"/>
+            <a:ext cx="713232" cy="713232"/>
+          </a:xfrm>
+          <a:prstGeom prst="rect">
+            <a:avLst/>
+          </a:prstGeom>
+        </p:spPr>
+      </p:pic>
+      <p:sp>
+        <p:nvSpPr>
+          <p:cNvPr id="7" name="TextBox 6"/>
+          <p:cNvSpPr txBox="1"/>
+          <p:nvPr/>
+        </p:nvSpPr>
+        <p:spPr>
+          <a:xfrm>
+            <a:off x="1618488" y="4434840"/>
+            <a:ext cx="3015234" cy="1005840"/>
+          </a:xfrm>
+          <a:prstGeom prst="rect">
+            <a:avLst/>
+          </a:prstGeom>
+          <a:noFill/>
+        </p:spPr>
+        <p:txBody>
+          <a:bodyPr wrap="square" lIns="0" rIns="0" tIns="0" bIns="0">
+            <a:spAutoFit/>
+          </a:bodyPr>
+          <a:lstStyle/>
+          <a:p>
+            <a:pPr algn="l">
+              <a:lnSpc>
+                <a:spcPct val="115000"/>
+              </a:lnSpc>
+              <a:spcAft>
+                <a:spcPts val="0"/>
+              </a:spcAft>
+            </a:pPr>
+            <a:r>
+              <a:rPr sz="2000" b="1">
+                <a:solidFill>
+                  <a:srgbClr val="111111"/>
+                </a:solidFill>
+                <a:latin typeface="Poppins"/>
+              </a:rPr>
+              <a:t>Enter the cuts</a:t>
+            </a:r>
+          </a:p>
+        </p:txBody>
+      </p:sp>
+      <p:sp>
+        <p:nvSpPr>
+          <p:cNvPr id="8" name="TextBox 7"/>
+          <p:cNvSpPr txBox="1"/>
+          <p:nvPr/>
+        </p:nvSpPr>
+        <p:spPr>
+          <a:xfrm>
+            <a:off x="1618488" y="5394960"/>
+            <a:ext cx="3015234" cy="2697480"/>
+          </a:xfrm>
+          <a:prstGeom prst="rect">
+            <a:avLst/>
+          </a:prstGeom>
+          <a:noFill/>
+        </p:spPr>
+        <p:txBody>
+          <a:bodyPr wrap="square" lIns="0" rIns="0" tIns="0" bIns="0">
+            <a:spAutoFit/>
+          </a:bodyPr>
+          <a:lstStyle/>
+          <a:p>
+            <a:pPr algn="l">
+              <a:lnSpc>
+                <a:spcPct val="135000"/>
+              </a:lnSpc>
+              <a:spcAft>
+                <a:spcPts val="0"/>
+              </a:spcAft>
+            </a:pPr>
+            <a:r>
+              <a:rPr sz="1600" b="0">
+                <a:solidFill>
+                  <a:srgbClr val="5D6880"/>
+                </a:solidFill>
+                <a:latin typeface="Poppins"/>
+              </a:rPr>
+              <a:t>Start and end time for each announced cut, drawn on a </a:t>
+            </a:r>
+            <a:r>
+              <a:rPr sz="1600" b="1">
+                <a:solidFill>
+                  <a:srgbClr val="8A5D05"/>
+                </a:solidFill>
+                <a:latin typeface="Poppins"/>
+              </a:rPr>
+              <a:t>24-hour timeline</a:t>
+            </a:r>
+            <a:r>
+              <a:rPr sz="1600" b="0">
+                <a:solidFill>
+                  <a:srgbClr val="5D6880"/>
+                </a:solidFill>
+                <a:latin typeface="Poppins"/>
+              </a:rPr>
+              <a:t>.</a:t>
+            </a:r>
+          </a:p>
+        </p:txBody>
+      </p:sp>
+      <p:sp>
+        <p:nvSpPr>
+          <p:cNvPr id="9" name="Rounded Rectangle 8"/>
           <p:cNvSpPr/>
           <p:nvPr/>
         </p:nvSpPr>
         <p:spPr>
           <a:xfrm>
-            <a:off x="1618488" y="3538728"/>
-            <a:ext cx="566928" cy="566928"/>
+            <a:off x="5246370" y="3108960"/>
+            <a:ext cx="3783330" cy="5394960"/>
           </a:xfrm>
           <a:prstGeom prst="roundRect">
             <a:avLst>
@@ -4645,10 +4795,12 @@
             </a:avLst>
           </a:prstGeom>
           <a:solidFill>
-            <a:srgbClr val="F8C238"/>
+            <a:srgbClr val="FFFFFF"/>
           </a:solidFill>
-          <a:ln>
-            <a:noFill/>
+          <a:ln w="12700">
+            <a:solidFill>
+              <a:srgbClr val="E8E3D6"/>
+            </a:solidFill>
           </a:ln>
           <a:effectLst/>
         </p:spPr>
@@ -4669,30 +4821,43 @@
         <p:txBody>
           <a:bodyPr rtlCol="0" anchor="ctr"/>
           <a:lstStyle/>
-          <a:p>
-            <a:pPr algn="ctr"/>
-            <a:r>
-              <a:rPr sz="1800" b="1">
-                <a:solidFill>
-                  <a:srgbClr val="111111"/>
-                </a:solidFill>
-                <a:latin typeface="Poppins"/>
-              </a:rPr>
-              <a:t>R1</a:t>
-            </a:r>
-          </a:p>
-        </p:txBody>
-      </p:sp>
-      <p:sp>
-        <p:nvSpPr>
-          <p:cNvPr id="7" name="TextBox 6"/>
+          <a:p/>
+        </p:txBody>
+      </p:sp>
+      <p:pic>
+        <p:nvPicPr>
+          <p:cNvPr id="10" name="Picture 9" descr="badge-2.png"/>
+          <p:cNvPicPr>
+            <a:picLocks noChangeAspect="1"/>
+          </p:cNvPicPr>
+          <p:nvPr/>
+        </p:nvPicPr>
+        <p:blipFill>
+          <a:blip r:embed="rId3"/>
+          <a:stretch>
+            <a:fillRect/>
+          </a:stretch>
+        </p:blipFill>
+        <p:spPr>
+          <a:xfrm>
+            <a:off x="5630418" y="3493008"/>
+            <a:ext cx="713232" cy="713232"/>
+          </a:xfrm>
+          <a:prstGeom prst="rect">
+            <a:avLst/>
+          </a:prstGeom>
+        </p:spPr>
+      </p:pic>
+      <p:sp>
+        <p:nvSpPr>
+          <p:cNvPr id="11" name="TextBox 10"/>
           <p:cNvSpPr txBox="1"/>
           <p:nvPr/>
         </p:nvSpPr>
         <p:spPr>
           <a:xfrm>
-            <a:off x="2404872" y="3575304"/>
-            <a:ext cx="2320290" cy="1005840"/>
+            <a:off x="5630418" y="4434840"/>
+            <a:ext cx="3015234" cy="1005840"/>
           </a:xfrm>
           <a:prstGeom prst="rect">
             <a:avLst/>
@@ -4720,21 +4885,21 @@
                 </a:solidFill>
                 <a:latin typeface="Poppins"/>
               </a:rPr>
-              <a:t>Enter the cuts</a:t>
-            </a:r>
-          </a:p>
-        </p:txBody>
-      </p:sp>
-      <p:sp>
-        <p:nvSpPr>
-          <p:cNvPr id="8" name="TextBox 7"/>
+              <a:t>Add the jobs</a:t>
+            </a:r>
+          </a:p>
+        </p:txBody>
+      </p:sp>
+      <p:sp>
+        <p:nvSpPr>
+          <p:cNvPr id="12" name="TextBox 11"/>
           <p:cNvSpPr txBox="1"/>
           <p:nvPr/>
         </p:nvSpPr>
         <p:spPr>
           <a:xfrm>
-            <a:off x="1618488" y="4846320"/>
-            <a:ext cx="3015234" cy="1920240"/>
+            <a:off x="5630418" y="5394960"/>
+            <a:ext cx="3015234" cy="2697480"/>
           </a:xfrm>
           <a:prstGeom prst="rect">
             <a:avLst/>
@@ -4762,7 +4927,7 @@
                 </a:solidFill>
                 <a:latin typeface="Poppins"/>
               </a:rPr>
-              <a:t>Start and end time for each announced cut, drawn on a </a:t>
+              <a:t>Name, duration, and what power it needs: </a:t>
             </a:r>
             <a:r>
               <a:rPr sz="1600" b="1">
@@ -4771,7 +4936,7 @@
                 </a:solidFill>
                 <a:latin typeface="Poppins"/>
               </a:rPr>
-              <a:t>24-hour timeline</a:t>
+              <a:t>grid</a:t>
             </a:r>
             <a:r>
               <a:rPr sz="1600" b="0">
@@ -4780,6 +4945,42 @@
                 </a:solidFill>
                 <a:latin typeface="Poppins"/>
               </a:rPr>
+              <a:t>, </a:t>
+            </a:r>
+            <a:r>
+              <a:rPr sz="1600" b="1">
+                <a:solidFill>
+                  <a:srgbClr val="8A5D05"/>
+                </a:solidFill>
+                <a:latin typeface="Poppins"/>
+              </a:rPr>
+              <a:t>generator</a:t>
+            </a:r>
+            <a:r>
+              <a:rPr sz="1600" b="0">
+                <a:solidFill>
+                  <a:srgbClr val="5D6880"/>
+                </a:solidFill>
+                <a:latin typeface="Poppins"/>
+              </a:rPr>
+              <a:t> or </a:t>
+            </a:r>
+            <a:r>
+              <a:rPr sz="1600" b="1">
+                <a:solidFill>
+                  <a:srgbClr val="8A5D05"/>
+                </a:solidFill>
+                <a:latin typeface="Poppins"/>
+              </a:rPr>
+              <a:t>none</a:t>
+            </a:r>
+            <a:r>
+              <a:rPr sz="1600" b="0">
+                <a:solidFill>
+                  <a:srgbClr val="5D6880"/>
+                </a:solidFill>
+                <a:latin typeface="Poppins"/>
+              </a:rPr>
               <a:t>.</a:t>
             </a:r>
           </a:p>
@@ -4787,14 +4988,14 @@
       </p:sp>
       <p:sp>
         <p:nvSpPr>
-          <p:cNvPr id="9" name="Rounded Rectangle 8"/>
+          <p:cNvPr id="13" name="Rounded Rectangle 12"/>
           <p:cNvSpPr/>
           <p:nvPr/>
         </p:nvSpPr>
         <p:spPr>
           <a:xfrm>
-            <a:off x="5246370" y="3154680"/>
-            <a:ext cx="3783330" cy="4023360"/>
+            <a:off x="9258300" y="3108960"/>
+            <a:ext cx="3783330" cy="5394960"/>
           </a:xfrm>
           <a:prstGeom prst="roundRect">
             <a:avLst>
@@ -4831,16 +5032,142 @@
           <a:p/>
         </p:txBody>
       </p:sp>
-      <p:sp>
-        <p:nvSpPr>
-          <p:cNvPr id="10" name="Rounded Rectangle 9"/>
+      <p:pic>
+        <p:nvPicPr>
+          <p:cNvPr id="14" name="Picture 13" descr="badge-3.png"/>
+          <p:cNvPicPr>
+            <a:picLocks noChangeAspect="1"/>
+          </p:cNvPicPr>
+          <p:nvPr/>
+        </p:nvPicPr>
+        <p:blipFill>
+          <a:blip r:embed="rId4"/>
+          <a:stretch>
+            <a:fillRect/>
+          </a:stretch>
+        </p:blipFill>
+        <p:spPr>
+          <a:xfrm>
+            <a:off x="9642348" y="3493008"/>
+            <a:ext cx="713232" cy="713232"/>
+          </a:xfrm>
+          <a:prstGeom prst="rect">
+            <a:avLst/>
+          </a:prstGeom>
+        </p:spPr>
+      </p:pic>
+      <p:sp>
+        <p:nvSpPr>
+          <p:cNvPr id="15" name="TextBox 14"/>
+          <p:cNvSpPr txBox="1"/>
+          <p:nvPr/>
+        </p:nvSpPr>
+        <p:spPr>
+          <a:xfrm>
+            <a:off x="9642348" y="4434840"/>
+            <a:ext cx="3015234" cy="1005840"/>
+          </a:xfrm>
+          <a:prstGeom prst="rect">
+            <a:avLst/>
+          </a:prstGeom>
+          <a:noFill/>
+        </p:spPr>
+        <p:txBody>
+          <a:bodyPr wrap="square" lIns="0" rIns="0" tIns="0" bIns="0">
+            <a:spAutoFit/>
+          </a:bodyPr>
+          <a:lstStyle/>
+          <a:p>
+            <a:pPr algn="l">
+              <a:lnSpc>
+                <a:spcPct val="115000"/>
+              </a:lnSpc>
+              <a:spcAft>
+                <a:spcPts val="0"/>
+              </a:spcAft>
+            </a:pPr>
+            <a:r>
+              <a:rPr sz="2000" b="1">
+                <a:solidFill>
+                  <a:srgbClr val="111111"/>
+                </a:solidFill>
+                <a:latin typeface="Poppins"/>
+              </a:rPr>
+              <a:t>Place them automatically</a:t>
+            </a:r>
+          </a:p>
+        </p:txBody>
+      </p:sp>
+      <p:sp>
+        <p:nvSpPr>
+          <p:cNvPr id="16" name="TextBox 15"/>
+          <p:cNvSpPr txBox="1"/>
+          <p:nvPr/>
+        </p:nvSpPr>
+        <p:spPr>
+          <a:xfrm>
+            <a:off x="9642348" y="5394960"/>
+            <a:ext cx="3015234" cy="2697480"/>
+          </a:xfrm>
+          <a:prstGeom prst="rect">
+            <a:avLst/>
+          </a:prstGeom>
+          <a:noFill/>
+        </p:spPr>
+        <p:txBody>
+          <a:bodyPr wrap="square" lIns="0" rIns="0" tIns="0" bIns="0">
+            <a:spAutoFit/>
+          </a:bodyPr>
+          <a:lstStyle/>
+          <a:p>
+            <a:pPr algn="l">
+              <a:lnSpc>
+                <a:spcPct val="135000"/>
+              </a:lnSpc>
+              <a:spcAft>
+                <a:spcPts val="0"/>
+              </a:spcAft>
+            </a:pPr>
+            <a:r>
+              <a:rPr sz="1600" b="0">
+                <a:solidFill>
+                  <a:srgbClr val="5D6880"/>
+                </a:solidFill>
+                <a:latin typeface="Poppins"/>
+              </a:rPr>
+              <a:t>No job needing grid power may </a:t>
+            </a:r>
+            <a:r>
+              <a:rPr sz="1600" b="1">
+                <a:solidFill>
+                  <a:srgbClr val="5D6880"/>
+                </a:solidFill>
+                <a:latin typeface="Poppins"/>
+              </a:rPr>
+              <a:t>ever</a:t>
+            </a:r>
+            <a:r>
+              <a:rPr sz="1600" b="0">
+                <a:solidFill>
+                  <a:srgbClr val="5D6880"/>
+                </a:solidFill>
+                <a:latin typeface="Poppins"/>
+              </a:rPr>
+              <a:t> land inside a cut. Plan shown beside the cut bars.</a:t>
+            </a:r>
+          </a:p>
+        </p:txBody>
+      </p:sp>
+      <p:sp>
+        <p:nvSpPr>
+          <p:cNvPr id="17" name="Rounded Rectangle 16"/>
           <p:cNvSpPr/>
           <p:nvPr/>
         </p:nvSpPr>
         <p:spPr>
           <a:xfrm>
-            <a:off x="5630418" y="3538728"/>
-            <a:ext cx="566928" cy="566928"/>
+            <a:off x="13270230" y="3108960"/>
+            <a:ext cx="3783330" cy="5394960"/>
           </a:xfrm>
           <a:prstGeom prst="roundRect">
             <a:avLst>
@@ -4848,10 +5175,12 @@
             </a:avLst>
           </a:prstGeom>
           <a:solidFill>
-            <a:srgbClr val="F8C238"/>
+            <a:srgbClr val="FFFFFF"/>
           </a:solidFill>
-          <a:ln>
-            <a:noFill/>
+          <a:ln w="12700">
+            <a:solidFill>
+              <a:srgbClr val="E8E3D6"/>
+            </a:solidFill>
           </a:ln>
           <a:effectLst/>
         </p:spPr>
@@ -4872,30 +5201,43 @@
         <p:txBody>
           <a:bodyPr rtlCol="0" anchor="ctr"/>
           <a:lstStyle/>
-          <a:p>
-            <a:pPr algn="ctr"/>
-            <a:r>
-              <a:rPr sz="1800" b="1">
-                <a:solidFill>
-                  <a:srgbClr val="111111"/>
-                </a:solidFill>
-                <a:latin typeface="Poppins"/>
-              </a:rPr>
-              <a:t>R2</a:t>
-            </a:r>
-          </a:p>
-        </p:txBody>
-      </p:sp>
-      <p:sp>
-        <p:nvSpPr>
-          <p:cNvPr id="11" name="TextBox 10"/>
+          <a:p/>
+        </p:txBody>
+      </p:sp>
+      <p:pic>
+        <p:nvPicPr>
+          <p:cNvPr id="18" name="Picture 17" descr="badge-4.png"/>
+          <p:cNvPicPr>
+            <a:picLocks noChangeAspect="1"/>
+          </p:cNvPicPr>
+          <p:nvPr/>
+        </p:nvPicPr>
+        <p:blipFill>
+          <a:blip r:embed="rId5"/>
+          <a:stretch>
+            <a:fillRect/>
+          </a:stretch>
+        </p:blipFill>
+        <p:spPr>
+          <a:xfrm>
+            <a:off x="13654278" y="3493008"/>
+            <a:ext cx="713232" cy="713232"/>
+          </a:xfrm>
+          <a:prstGeom prst="rect">
+            <a:avLst/>
+          </a:prstGeom>
+        </p:spPr>
+      </p:pic>
+      <p:sp>
+        <p:nvSpPr>
+          <p:cNvPr id="19" name="TextBox 18"/>
           <p:cNvSpPr txBox="1"/>
           <p:nvPr/>
         </p:nvSpPr>
         <p:spPr>
           <a:xfrm>
-            <a:off x="6416802" y="3575304"/>
-            <a:ext cx="2320290" cy="1005840"/>
+            <a:off x="13654278" y="4434840"/>
+            <a:ext cx="3015234" cy="1005840"/>
           </a:xfrm>
           <a:prstGeom prst="rect">
             <a:avLst/>
@@ -4923,448 +5265,6 @@
                 </a:solidFill>
                 <a:latin typeface="Poppins"/>
               </a:rPr>
-              <a:t>Add the jobs</a:t>
-            </a:r>
-          </a:p>
-        </p:txBody>
-      </p:sp>
-      <p:sp>
-        <p:nvSpPr>
-          <p:cNvPr id="12" name="TextBox 11"/>
-          <p:cNvSpPr txBox="1"/>
-          <p:nvPr/>
-        </p:nvSpPr>
-        <p:spPr>
-          <a:xfrm>
-            <a:off x="5630418" y="4846320"/>
-            <a:ext cx="3015234" cy="1920240"/>
-          </a:xfrm>
-          <a:prstGeom prst="rect">
-            <a:avLst/>
-          </a:prstGeom>
-          <a:noFill/>
-        </p:spPr>
-        <p:txBody>
-          <a:bodyPr wrap="square" lIns="0" rIns="0" tIns="0" bIns="0">
-            <a:spAutoFit/>
-          </a:bodyPr>
-          <a:lstStyle/>
-          <a:p>
-            <a:pPr algn="l">
-              <a:lnSpc>
-                <a:spcPct val="135000"/>
-              </a:lnSpc>
-              <a:spcAft>
-                <a:spcPts val="0"/>
-              </a:spcAft>
-            </a:pPr>
-            <a:r>
-              <a:rPr sz="1600" b="0">
-                <a:solidFill>
-                  <a:srgbClr val="5D6880"/>
-                </a:solidFill>
-                <a:latin typeface="Poppins"/>
-              </a:rPr>
-              <a:t>Name, duration, and what power it needs: </a:t>
-            </a:r>
-            <a:r>
-              <a:rPr sz="1600" b="1">
-                <a:solidFill>
-                  <a:srgbClr val="8A5D05"/>
-                </a:solidFill>
-                <a:latin typeface="Poppins"/>
-              </a:rPr>
-              <a:t>grid</a:t>
-            </a:r>
-            <a:r>
-              <a:rPr sz="1600" b="0">
-                <a:solidFill>
-                  <a:srgbClr val="5D6880"/>
-                </a:solidFill>
-                <a:latin typeface="Poppins"/>
-              </a:rPr>
-              <a:t>, </a:t>
-            </a:r>
-            <a:r>
-              <a:rPr sz="1600" b="1">
-                <a:solidFill>
-                  <a:srgbClr val="8A5D05"/>
-                </a:solidFill>
-                <a:latin typeface="Poppins"/>
-              </a:rPr>
-              <a:t>generator</a:t>
-            </a:r>
-            <a:r>
-              <a:rPr sz="1600" b="0">
-                <a:solidFill>
-                  <a:srgbClr val="5D6880"/>
-                </a:solidFill>
-                <a:latin typeface="Poppins"/>
-              </a:rPr>
-              <a:t> or </a:t>
-            </a:r>
-            <a:r>
-              <a:rPr sz="1600" b="1">
-                <a:solidFill>
-                  <a:srgbClr val="8A5D05"/>
-                </a:solidFill>
-                <a:latin typeface="Poppins"/>
-              </a:rPr>
-              <a:t>none</a:t>
-            </a:r>
-            <a:r>
-              <a:rPr sz="1600" b="0">
-                <a:solidFill>
-                  <a:srgbClr val="5D6880"/>
-                </a:solidFill>
-                <a:latin typeface="Poppins"/>
-              </a:rPr>
-              <a:t>.</a:t>
-            </a:r>
-          </a:p>
-        </p:txBody>
-      </p:sp>
-      <p:sp>
-        <p:nvSpPr>
-          <p:cNvPr id="13" name="Rounded Rectangle 12"/>
-          <p:cNvSpPr/>
-          <p:nvPr/>
-        </p:nvSpPr>
-        <p:spPr>
-          <a:xfrm>
-            <a:off x="9258300" y="3154680"/>
-            <a:ext cx="3783330" cy="4023360"/>
-          </a:xfrm>
-          <a:prstGeom prst="roundRect">
-            <a:avLst>
-              <a:gd name="adj" fmla="val 8000"/>
-            </a:avLst>
-          </a:prstGeom>
-          <a:solidFill>
-            <a:srgbClr val="FFFFFF"/>
-          </a:solidFill>
-          <a:ln w="12700">
-            <a:solidFill>
-              <a:srgbClr val="E8E3D6"/>
-            </a:solidFill>
-          </a:ln>
-          <a:effectLst/>
-        </p:spPr>
-        <p:style>
-          <a:lnRef idx="1">
-            <a:schemeClr val="accent1"/>
-          </a:lnRef>
-          <a:fillRef idx="3">
-            <a:schemeClr val="accent1"/>
-          </a:fillRef>
-          <a:effectRef idx="2">
-            <a:schemeClr val="accent1"/>
-          </a:effectRef>
-          <a:fontRef idx="minor">
-            <a:schemeClr val="lt1"/>
-          </a:fontRef>
-        </p:style>
-        <p:txBody>
-          <a:bodyPr rtlCol="0" anchor="ctr"/>
-          <a:lstStyle/>
-          <a:p/>
-        </p:txBody>
-      </p:sp>
-      <p:sp>
-        <p:nvSpPr>
-          <p:cNvPr id="14" name="Rounded Rectangle 13"/>
-          <p:cNvSpPr/>
-          <p:nvPr/>
-        </p:nvSpPr>
-        <p:spPr>
-          <a:xfrm>
-            <a:off x="9642348" y="3538728"/>
-            <a:ext cx="566928" cy="566928"/>
-          </a:xfrm>
-          <a:prstGeom prst="roundRect">
-            <a:avLst>
-              <a:gd name="adj" fmla="val 8000"/>
-            </a:avLst>
-          </a:prstGeom>
-          <a:solidFill>
-            <a:srgbClr val="F8C238"/>
-          </a:solidFill>
-          <a:ln>
-            <a:noFill/>
-          </a:ln>
-          <a:effectLst/>
-        </p:spPr>
-        <p:style>
-          <a:lnRef idx="1">
-            <a:schemeClr val="accent1"/>
-          </a:lnRef>
-          <a:fillRef idx="3">
-            <a:schemeClr val="accent1"/>
-          </a:fillRef>
-          <a:effectRef idx="2">
-            <a:schemeClr val="accent1"/>
-          </a:effectRef>
-          <a:fontRef idx="minor">
-            <a:schemeClr val="lt1"/>
-          </a:fontRef>
-        </p:style>
-        <p:txBody>
-          <a:bodyPr rtlCol="0" anchor="ctr"/>
-          <a:lstStyle/>
-          <a:p>
-            <a:pPr algn="ctr"/>
-            <a:r>
-              <a:rPr sz="1800" b="1">
-                <a:solidFill>
-                  <a:srgbClr val="111111"/>
-                </a:solidFill>
-                <a:latin typeface="Poppins"/>
-              </a:rPr>
-              <a:t>R3</a:t>
-            </a:r>
-          </a:p>
-        </p:txBody>
-      </p:sp>
-      <p:sp>
-        <p:nvSpPr>
-          <p:cNvPr id="15" name="TextBox 14"/>
-          <p:cNvSpPr txBox="1"/>
-          <p:nvPr/>
-        </p:nvSpPr>
-        <p:spPr>
-          <a:xfrm>
-            <a:off x="10428732" y="3575304"/>
-            <a:ext cx="2320290" cy="1005840"/>
-          </a:xfrm>
-          <a:prstGeom prst="rect">
-            <a:avLst/>
-          </a:prstGeom>
-          <a:noFill/>
-        </p:spPr>
-        <p:txBody>
-          <a:bodyPr wrap="square" lIns="0" rIns="0" tIns="0" bIns="0">
-            <a:spAutoFit/>
-          </a:bodyPr>
-          <a:lstStyle/>
-          <a:p>
-            <a:pPr algn="l">
-              <a:lnSpc>
-                <a:spcPct val="115000"/>
-              </a:lnSpc>
-              <a:spcAft>
-                <a:spcPts val="0"/>
-              </a:spcAft>
-            </a:pPr>
-            <a:r>
-              <a:rPr sz="2000" b="1">
-                <a:solidFill>
-                  <a:srgbClr val="111111"/>
-                </a:solidFill>
-                <a:latin typeface="Poppins"/>
-              </a:rPr>
-              <a:t>Place them automatically</a:t>
-            </a:r>
-          </a:p>
-        </p:txBody>
-      </p:sp>
-      <p:sp>
-        <p:nvSpPr>
-          <p:cNvPr id="16" name="TextBox 15"/>
-          <p:cNvSpPr txBox="1"/>
-          <p:nvPr/>
-        </p:nvSpPr>
-        <p:spPr>
-          <a:xfrm>
-            <a:off x="9642348" y="4846320"/>
-            <a:ext cx="3015234" cy="1920240"/>
-          </a:xfrm>
-          <a:prstGeom prst="rect">
-            <a:avLst/>
-          </a:prstGeom>
-          <a:noFill/>
-        </p:spPr>
-        <p:txBody>
-          <a:bodyPr wrap="square" lIns="0" rIns="0" tIns="0" bIns="0">
-            <a:spAutoFit/>
-          </a:bodyPr>
-          <a:lstStyle/>
-          <a:p>
-            <a:pPr algn="l">
-              <a:lnSpc>
-                <a:spcPct val="135000"/>
-              </a:lnSpc>
-              <a:spcAft>
-                <a:spcPts val="0"/>
-              </a:spcAft>
-            </a:pPr>
-            <a:r>
-              <a:rPr sz="1600" b="0">
-                <a:solidFill>
-                  <a:srgbClr val="5D6880"/>
-                </a:solidFill>
-                <a:latin typeface="Poppins"/>
-              </a:rPr>
-              <a:t>No job needing grid power may </a:t>
-            </a:r>
-            <a:r>
-              <a:rPr sz="1600" b="1">
-                <a:solidFill>
-                  <a:srgbClr val="5D6880"/>
-                </a:solidFill>
-                <a:latin typeface="Poppins"/>
-              </a:rPr>
-              <a:t>ever</a:t>
-            </a:r>
-            <a:r>
-              <a:rPr sz="1600" b="0">
-                <a:solidFill>
-                  <a:srgbClr val="5D6880"/>
-                </a:solidFill>
-                <a:latin typeface="Poppins"/>
-              </a:rPr>
-              <a:t> land inside a cut. Plan shown beside the cut bars.</a:t>
-            </a:r>
-          </a:p>
-        </p:txBody>
-      </p:sp>
-      <p:sp>
-        <p:nvSpPr>
-          <p:cNvPr id="17" name="Rounded Rectangle 16"/>
-          <p:cNvSpPr/>
-          <p:nvPr/>
-        </p:nvSpPr>
-        <p:spPr>
-          <a:xfrm>
-            <a:off x="13270230" y="3154680"/>
-            <a:ext cx="3783330" cy="4023360"/>
-          </a:xfrm>
-          <a:prstGeom prst="roundRect">
-            <a:avLst>
-              <a:gd name="adj" fmla="val 8000"/>
-            </a:avLst>
-          </a:prstGeom>
-          <a:solidFill>
-            <a:srgbClr val="FFFFFF"/>
-          </a:solidFill>
-          <a:ln w="12700">
-            <a:solidFill>
-              <a:srgbClr val="E8E3D6"/>
-            </a:solidFill>
-          </a:ln>
-          <a:effectLst/>
-        </p:spPr>
-        <p:style>
-          <a:lnRef idx="1">
-            <a:schemeClr val="accent1"/>
-          </a:lnRef>
-          <a:fillRef idx="3">
-            <a:schemeClr val="accent1"/>
-          </a:fillRef>
-          <a:effectRef idx="2">
-            <a:schemeClr val="accent1"/>
-          </a:effectRef>
-          <a:fontRef idx="minor">
-            <a:schemeClr val="lt1"/>
-          </a:fontRef>
-        </p:style>
-        <p:txBody>
-          <a:bodyPr rtlCol="0" anchor="ctr"/>
-          <a:lstStyle/>
-          <a:p/>
-        </p:txBody>
-      </p:sp>
-      <p:sp>
-        <p:nvSpPr>
-          <p:cNvPr id="18" name="Rounded Rectangle 17"/>
-          <p:cNvSpPr/>
-          <p:nvPr/>
-        </p:nvSpPr>
-        <p:spPr>
-          <a:xfrm>
-            <a:off x="13654278" y="3538728"/>
-            <a:ext cx="566928" cy="566928"/>
-          </a:xfrm>
-          <a:prstGeom prst="roundRect">
-            <a:avLst>
-              <a:gd name="adj" fmla="val 8000"/>
-            </a:avLst>
-          </a:prstGeom>
-          <a:solidFill>
-            <a:srgbClr val="F8C238"/>
-          </a:solidFill>
-          <a:ln>
-            <a:noFill/>
-          </a:ln>
-          <a:effectLst/>
-        </p:spPr>
-        <p:style>
-          <a:lnRef idx="1">
-            <a:schemeClr val="accent1"/>
-          </a:lnRef>
-          <a:fillRef idx="3">
-            <a:schemeClr val="accent1"/>
-          </a:fillRef>
-          <a:effectRef idx="2">
-            <a:schemeClr val="accent1"/>
-          </a:effectRef>
-          <a:fontRef idx="minor">
-            <a:schemeClr val="lt1"/>
-          </a:fontRef>
-        </p:style>
-        <p:txBody>
-          <a:bodyPr rtlCol="0" anchor="ctr"/>
-          <a:lstStyle/>
-          <a:p>
-            <a:pPr algn="ctr"/>
-            <a:r>
-              <a:rPr sz="1800" b="1">
-                <a:solidFill>
-                  <a:srgbClr val="111111"/>
-                </a:solidFill>
-                <a:latin typeface="Poppins"/>
-              </a:rPr>
-              <a:t>R4</a:t>
-            </a:r>
-          </a:p>
-        </p:txBody>
-      </p:sp>
-      <p:sp>
-        <p:nvSpPr>
-          <p:cNvPr id="19" name="TextBox 18"/>
-          <p:cNvSpPr txBox="1"/>
-          <p:nvPr/>
-        </p:nvSpPr>
-        <p:spPr>
-          <a:xfrm>
-            <a:off x="14440662" y="3575304"/>
-            <a:ext cx="2320290" cy="1005840"/>
-          </a:xfrm>
-          <a:prstGeom prst="rect">
-            <a:avLst/>
-          </a:prstGeom>
-          <a:noFill/>
-        </p:spPr>
-        <p:txBody>
-          <a:bodyPr wrap="square" lIns="0" rIns="0" tIns="0" bIns="0">
-            <a:spAutoFit/>
-          </a:bodyPr>
-          <a:lstStyle/>
-          <a:p>
-            <a:pPr algn="l">
-              <a:lnSpc>
-                <a:spcPct val="115000"/>
-              </a:lnSpc>
-              <a:spcAft>
-                <a:spcPts val="0"/>
-              </a:spcAft>
-            </a:pPr>
-            <a:r>
-              <a:rPr sz="2000" b="1">
-                <a:solidFill>
-                  <a:srgbClr val="111111"/>
-                </a:solidFill>
-                <a:latin typeface="Poppins"/>
-              </a:rPr>
               <a:t>Count generator minutes</a:t>
             </a:r>
           </a:p>
@@ -5378,8 +5278,8 @@
         </p:nvSpPr>
         <p:spPr>
           <a:xfrm>
-            <a:off x="13654278" y="4846320"/>
-            <a:ext cx="3015234" cy="1920240"/>
+            <a:off x="13654278" y="5394960"/>
+            <a:ext cx="3015234" cy="2697480"/>
           </a:xfrm>
           <a:prstGeom prst="rect">
             <a:avLst/>
@@ -5859,8 +5759,8 @@
         </p:nvSpPr>
         <p:spPr>
           <a:xfrm>
-            <a:off x="1234440" y="3154680"/>
-            <a:ext cx="5090160" cy="3200400"/>
+            <a:off x="1234440" y="3108960"/>
+            <a:ext cx="5090160" cy="4754880"/>
           </a:xfrm>
           <a:prstGeom prst="roundRect">
             <a:avLst>
@@ -5897,16 +5797,142 @@
           <a:p/>
         </p:txBody>
       </p:sp>
-      <p:sp>
-        <p:nvSpPr>
-          <p:cNvPr id="6" name="Rounded Rectangle 5"/>
+      <p:pic>
+        <p:nvPicPr>
+          <p:cNvPr id="6" name="Picture 5" descr="badge-a1.png"/>
+          <p:cNvPicPr>
+            <a:picLocks noChangeAspect="1"/>
+          </p:cNvPicPr>
+          <p:nvPr/>
+        </p:nvPicPr>
+        <p:blipFill>
+          <a:blip r:embed="rId2"/>
+          <a:stretch>
+            <a:fillRect/>
+          </a:stretch>
+        </p:blipFill>
+        <p:spPr>
+          <a:xfrm>
+            <a:off x="1618488" y="3493008"/>
+            <a:ext cx="713232" cy="713232"/>
+          </a:xfrm>
+          <a:prstGeom prst="rect">
+            <a:avLst/>
+          </a:prstGeom>
+        </p:spPr>
+      </p:pic>
+      <p:sp>
+        <p:nvSpPr>
+          <p:cNvPr id="7" name="TextBox 6"/>
+          <p:cNvSpPr txBox="1"/>
+          <p:nvPr/>
+        </p:nvSpPr>
+        <p:spPr>
+          <a:xfrm>
+            <a:off x="1618488" y="4434840"/>
+            <a:ext cx="4322064" cy="1005840"/>
+          </a:xfrm>
+          <a:prstGeom prst="rect">
+            <a:avLst/>
+          </a:prstGeom>
+          <a:noFill/>
+        </p:spPr>
+        <p:txBody>
+          <a:bodyPr wrap="square" lIns="0" rIns="0" tIns="0" bIns="0">
+            <a:spAutoFit/>
+          </a:bodyPr>
+          <a:lstStyle/>
+          <a:p>
+            <a:pPr algn="l">
+              <a:lnSpc>
+                <a:spcPct val="115000"/>
+              </a:lnSpc>
+              <a:spcAft>
+                <a:spcPts val="0"/>
+              </a:spcAft>
+            </a:pPr>
+            <a:r>
+              <a:rPr sz="2000" b="1">
+                <a:solidFill>
+                  <a:srgbClr val="111111"/>
+                </a:solidFill>
+                <a:latin typeface="Poppins"/>
+              </a:rPr>
+              <a:t>Grid jobs</a:t>
+            </a:r>
+          </a:p>
+        </p:txBody>
+      </p:sp>
+      <p:sp>
+        <p:nvSpPr>
+          <p:cNvPr id="8" name="TextBox 7"/>
+          <p:cNvSpPr txBox="1"/>
+          <p:nvPr/>
+        </p:nvSpPr>
+        <p:spPr>
+          <a:xfrm>
+            <a:off x="1618488" y="5394960"/>
+            <a:ext cx="4322064" cy="2057400"/>
+          </a:xfrm>
+          <a:prstGeom prst="rect">
+            <a:avLst/>
+          </a:prstGeom>
+          <a:noFill/>
+        </p:spPr>
+        <p:txBody>
+          <a:bodyPr wrap="square" lIns="0" rIns="0" tIns="0" bIns="0">
+            <a:spAutoFit/>
+          </a:bodyPr>
+          <a:lstStyle/>
+          <a:p>
+            <a:pPr algn="l">
+              <a:lnSpc>
+                <a:spcPct val="135000"/>
+              </a:lnSpc>
+              <a:spcAft>
+                <a:spcPts val="0"/>
+              </a:spcAft>
+            </a:pPr>
+            <a:r>
+              <a:rPr sz="1600" b="0">
+                <a:solidFill>
+                  <a:srgbClr val="5D6880"/>
+                </a:solidFill>
+                <a:latin typeface="Poppins"/>
+              </a:rPr>
+              <a:t>Cut-free space only. A </a:t>
+            </a:r>
+            <a:r>
+              <a:rPr sz="1600" b="1">
+                <a:solidFill>
+                  <a:srgbClr val="8A5D05"/>
+                </a:solidFill>
+                <a:latin typeface="Poppins"/>
+              </a:rPr>
+              <a:t>hard rule</a:t>
+            </a:r>
+            <a:r>
+              <a:rPr sz="1600" b="0">
+                <a:solidFill>
+                  <a:srgbClr val="5D6880"/>
+                </a:solidFill>
+                <a:latin typeface="Poppins"/>
+              </a:rPr>
+              <a:t> — if no gap is long enough the job is reported, never placed illegally.</a:t>
+            </a:r>
+          </a:p>
+        </p:txBody>
+      </p:sp>
+      <p:sp>
+        <p:nvSpPr>
+          <p:cNvPr id="9" name="Rounded Rectangle 8"/>
           <p:cNvSpPr/>
           <p:nvPr/>
         </p:nvSpPr>
         <p:spPr>
           <a:xfrm>
-            <a:off x="1618488" y="3538728"/>
-            <a:ext cx="566928" cy="566928"/>
+            <a:off x="6598920" y="3108960"/>
+            <a:ext cx="5090160" cy="4754880"/>
           </a:xfrm>
           <a:prstGeom prst="roundRect">
             <a:avLst>
@@ -5914,10 +5940,12 @@
             </a:avLst>
           </a:prstGeom>
           <a:solidFill>
-            <a:srgbClr val="F8C238"/>
+            <a:srgbClr val="FFFFFF"/>
           </a:solidFill>
-          <a:ln>
-            <a:noFill/>
+          <a:ln w="12700">
+            <a:solidFill>
+              <a:srgbClr val="E8E3D6"/>
+            </a:solidFill>
           </a:ln>
           <a:effectLst/>
         </p:spPr>
@@ -5938,30 +5966,43 @@
         <p:txBody>
           <a:bodyPr rtlCol="0" anchor="ctr"/>
           <a:lstStyle/>
-          <a:p>
-            <a:pPr algn="ctr"/>
-            <a:r>
-              <a:rPr sz="1800" b="1">
-                <a:solidFill>
-                  <a:srgbClr val="111111"/>
-                </a:solidFill>
-                <a:latin typeface="Poppins"/>
-              </a:rPr>
-              <a:t>1</a:t>
-            </a:r>
-          </a:p>
-        </p:txBody>
-      </p:sp>
-      <p:sp>
-        <p:nvSpPr>
-          <p:cNvPr id="7" name="TextBox 6"/>
+          <a:p/>
+        </p:txBody>
+      </p:sp>
+      <p:pic>
+        <p:nvPicPr>
+          <p:cNvPr id="10" name="Picture 9" descr="badge-a2.png"/>
+          <p:cNvPicPr>
+            <a:picLocks noChangeAspect="1"/>
+          </p:cNvPicPr>
+          <p:nvPr/>
+        </p:nvPicPr>
+        <p:blipFill>
+          <a:blip r:embed="rId3"/>
+          <a:stretch>
+            <a:fillRect/>
+          </a:stretch>
+        </p:blipFill>
+        <p:spPr>
+          <a:xfrm>
+            <a:off x="6982968" y="3493008"/>
+            <a:ext cx="713232" cy="713232"/>
+          </a:xfrm>
+          <a:prstGeom prst="rect">
+            <a:avLst/>
+          </a:prstGeom>
+        </p:spPr>
+      </p:pic>
+      <p:sp>
+        <p:nvSpPr>
+          <p:cNvPr id="11" name="TextBox 10"/>
           <p:cNvSpPr txBox="1"/>
           <p:nvPr/>
         </p:nvSpPr>
         <p:spPr>
           <a:xfrm>
-            <a:off x="2404872" y="3575304"/>
-            <a:ext cx="3627120" cy="1005840"/>
+            <a:off x="6982968" y="4434840"/>
+            <a:ext cx="4322064" cy="1005840"/>
           </a:xfrm>
           <a:prstGeom prst="rect">
             <a:avLst/>
@@ -5989,21 +6030,21 @@
                 </a:solidFill>
                 <a:latin typeface="Poppins"/>
               </a:rPr>
-              <a:t>Grid jobs</a:t>
-            </a:r>
-          </a:p>
-        </p:txBody>
-      </p:sp>
-      <p:sp>
-        <p:nvSpPr>
-          <p:cNvPr id="8" name="TextBox 7"/>
+              <a:t>Generator jobs</a:t>
+            </a:r>
+          </a:p>
+        </p:txBody>
+      </p:sp>
+      <p:sp>
+        <p:nvSpPr>
+          <p:cNvPr id="12" name="TextBox 11"/>
           <p:cNvSpPr txBox="1"/>
           <p:nvPr/>
         </p:nvSpPr>
         <p:spPr>
           <a:xfrm>
-            <a:off x="1618488" y="4846320"/>
-            <a:ext cx="4322064" cy="1097280"/>
+            <a:off x="6982968" y="5394960"/>
+            <a:ext cx="4322064" cy="2057400"/>
           </a:xfrm>
           <a:prstGeom prst="rect">
             <a:avLst/>
@@ -6031,7 +6072,7 @@
                 </a:solidFill>
                 <a:latin typeface="Poppins"/>
               </a:rPr>
-              <a:t>Cut-free space only. A </a:t>
+              <a:t>The slot costing the </a:t>
             </a:r>
             <a:r>
               <a:rPr sz="1600" b="1">
@@ -6040,7 +6081,7 @@
                 </a:solidFill>
                 <a:latin typeface="Poppins"/>
               </a:rPr>
-              <a:t>hard rule</a:t>
+              <a:t>fewest generator minutes</a:t>
             </a:r>
             <a:r>
               <a:rPr sz="1600" b="0">
@@ -6049,21 +6090,21 @@
                 </a:solidFill>
                 <a:latin typeface="Poppins"/>
               </a:rPr>
-              <a:t> — if no gap is long enough the job is reported, never placed illegally.</a:t>
-            </a:r>
-          </a:p>
-        </p:txBody>
-      </p:sp>
-      <p:sp>
-        <p:nvSpPr>
-          <p:cNvPr id="9" name="Rounded Rectangle 8"/>
+              <a:t>, not simply the earliest — because that cost is exactly what R4 reports.</a:t>
+            </a:r>
+          </a:p>
+        </p:txBody>
+      </p:sp>
+      <p:sp>
+        <p:nvSpPr>
+          <p:cNvPr id="13" name="Rounded Rectangle 12"/>
           <p:cNvSpPr/>
           <p:nvPr/>
         </p:nvSpPr>
         <p:spPr>
           <a:xfrm>
-            <a:off x="6598920" y="3154680"/>
-            <a:ext cx="5090160" cy="3200400"/>
+            <a:off x="11963400" y="3108960"/>
+            <a:ext cx="5090160" cy="4754880"/>
           </a:xfrm>
           <a:prstGeom prst="roundRect">
             <a:avLst>
@@ -6100,71 +6141,40 @@
           <a:p/>
         </p:txBody>
       </p:sp>
-      <p:sp>
-        <p:nvSpPr>
-          <p:cNvPr id="10" name="Rounded Rectangle 9"/>
-          <p:cNvSpPr/>
-          <p:nvPr/>
-        </p:nvSpPr>
-        <p:spPr>
-          <a:xfrm>
-            <a:off x="6982968" y="3538728"/>
-            <a:ext cx="566928" cy="566928"/>
-          </a:xfrm>
-          <a:prstGeom prst="roundRect">
-            <a:avLst>
-              <a:gd name="adj" fmla="val 8000"/>
-            </a:avLst>
-          </a:prstGeom>
-          <a:solidFill>
-            <a:srgbClr val="F8C238"/>
-          </a:solidFill>
-          <a:ln>
-            <a:noFill/>
-          </a:ln>
-          <a:effectLst/>
-        </p:spPr>
-        <p:style>
-          <a:lnRef idx="1">
-            <a:schemeClr val="accent1"/>
-          </a:lnRef>
-          <a:fillRef idx="3">
-            <a:schemeClr val="accent1"/>
-          </a:fillRef>
-          <a:effectRef idx="2">
-            <a:schemeClr val="accent1"/>
-          </a:effectRef>
-          <a:fontRef idx="minor">
-            <a:schemeClr val="lt1"/>
-          </a:fontRef>
-        </p:style>
-        <p:txBody>
-          <a:bodyPr rtlCol="0" anchor="ctr"/>
-          <a:lstStyle/>
-          <a:p>
-            <a:pPr algn="ctr"/>
-            <a:r>
-              <a:rPr sz="1800" b="1">
-                <a:solidFill>
-                  <a:srgbClr val="111111"/>
-                </a:solidFill>
-                <a:latin typeface="Poppins"/>
-              </a:rPr>
-              <a:t>2</a:t>
-            </a:r>
-          </a:p>
-        </p:txBody>
-      </p:sp>
-      <p:sp>
-        <p:nvSpPr>
-          <p:cNvPr id="11" name="TextBox 10"/>
+      <p:pic>
+        <p:nvPicPr>
+          <p:cNvPr id="14" name="Picture 13" descr="badge-a3.png"/>
+          <p:cNvPicPr>
+            <a:picLocks noChangeAspect="1"/>
+          </p:cNvPicPr>
+          <p:nvPr/>
+        </p:nvPicPr>
+        <p:blipFill>
+          <a:blip r:embed="rId4"/>
+          <a:stretch>
+            <a:fillRect/>
+          </a:stretch>
+        </p:blipFill>
+        <p:spPr>
+          <a:xfrm>
+            <a:off x="12347448" y="3493008"/>
+            <a:ext cx="713232" cy="713232"/>
+          </a:xfrm>
+          <a:prstGeom prst="rect">
+            <a:avLst/>
+          </a:prstGeom>
+        </p:spPr>
+      </p:pic>
+      <p:sp>
+        <p:nvSpPr>
+          <p:cNvPr id="15" name="TextBox 14"/>
           <p:cNvSpPr txBox="1"/>
           <p:nvPr/>
         </p:nvSpPr>
         <p:spPr>
           <a:xfrm>
-            <a:off x="7769352" y="3575304"/>
-            <a:ext cx="3627120" cy="1005840"/>
+            <a:off x="12347448" y="4434840"/>
+            <a:ext cx="4322064" cy="1005840"/>
           </a:xfrm>
           <a:prstGeom prst="rect">
             <a:avLst/>
@@ -6192,21 +6202,21 @@
                 </a:solidFill>
                 <a:latin typeface="Poppins"/>
               </a:rPr>
-              <a:t>Generator jobs</a:t>
-            </a:r>
-          </a:p>
-        </p:txBody>
-      </p:sp>
-      <p:sp>
-        <p:nvSpPr>
-          <p:cNvPr id="12" name="TextBox 11"/>
+              <a:t>No-power jobs</a:t>
+            </a:r>
+          </a:p>
+        </p:txBody>
+      </p:sp>
+      <p:sp>
+        <p:nvSpPr>
+          <p:cNvPr id="16" name="TextBox 15"/>
           <p:cNvSpPr txBox="1"/>
           <p:nvPr/>
         </p:nvSpPr>
         <p:spPr>
           <a:xfrm>
-            <a:off x="6982968" y="4846320"/>
-            <a:ext cx="4322064" cy="1097280"/>
+            <a:off x="12347448" y="5394960"/>
+            <a:ext cx="4322064" cy="2057400"/>
           </a:xfrm>
           <a:prstGeom prst="rect">
             <a:avLst/>
@@ -6234,209 +6244,6 @@
                 </a:solidFill>
                 <a:latin typeface="Poppins"/>
               </a:rPr>
-              <a:t>The slot costing the </a:t>
-            </a:r>
-            <a:r>
-              <a:rPr sz="1600" b="1">
-                <a:solidFill>
-                  <a:srgbClr val="8A5D05"/>
-                </a:solidFill>
-                <a:latin typeface="Poppins"/>
-              </a:rPr>
-              <a:t>fewest generator minutes</a:t>
-            </a:r>
-            <a:r>
-              <a:rPr sz="1600" b="0">
-                <a:solidFill>
-                  <a:srgbClr val="5D6880"/>
-                </a:solidFill>
-                <a:latin typeface="Poppins"/>
-              </a:rPr>
-              <a:t>, not simply the earliest — because that cost is exactly what R4 reports.</a:t>
-            </a:r>
-          </a:p>
-        </p:txBody>
-      </p:sp>
-      <p:sp>
-        <p:nvSpPr>
-          <p:cNvPr id="13" name="Rounded Rectangle 12"/>
-          <p:cNvSpPr/>
-          <p:nvPr/>
-        </p:nvSpPr>
-        <p:spPr>
-          <a:xfrm>
-            <a:off x="11963400" y="3154680"/>
-            <a:ext cx="5090160" cy="3200400"/>
-          </a:xfrm>
-          <a:prstGeom prst="roundRect">
-            <a:avLst>
-              <a:gd name="adj" fmla="val 8000"/>
-            </a:avLst>
-          </a:prstGeom>
-          <a:solidFill>
-            <a:srgbClr val="FFFFFF"/>
-          </a:solidFill>
-          <a:ln w="12700">
-            <a:solidFill>
-              <a:srgbClr val="E8E3D6"/>
-            </a:solidFill>
-          </a:ln>
-          <a:effectLst/>
-        </p:spPr>
-        <p:style>
-          <a:lnRef idx="1">
-            <a:schemeClr val="accent1"/>
-          </a:lnRef>
-          <a:fillRef idx="3">
-            <a:schemeClr val="accent1"/>
-          </a:fillRef>
-          <a:effectRef idx="2">
-            <a:schemeClr val="accent1"/>
-          </a:effectRef>
-          <a:fontRef idx="minor">
-            <a:schemeClr val="lt1"/>
-          </a:fontRef>
-        </p:style>
-        <p:txBody>
-          <a:bodyPr rtlCol="0" anchor="ctr"/>
-          <a:lstStyle/>
-          <a:p/>
-        </p:txBody>
-      </p:sp>
-      <p:sp>
-        <p:nvSpPr>
-          <p:cNvPr id="14" name="Rounded Rectangle 13"/>
-          <p:cNvSpPr/>
-          <p:nvPr/>
-        </p:nvSpPr>
-        <p:spPr>
-          <a:xfrm>
-            <a:off x="12347448" y="3538728"/>
-            <a:ext cx="566928" cy="566928"/>
-          </a:xfrm>
-          <a:prstGeom prst="roundRect">
-            <a:avLst>
-              <a:gd name="adj" fmla="val 8000"/>
-            </a:avLst>
-          </a:prstGeom>
-          <a:solidFill>
-            <a:srgbClr val="F8C238"/>
-          </a:solidFill>
-          <a:ln>
-            <a:noFill/>
-          </a:ln>
-          <a:effectLst/>
-        </p:spPr>
-        <p:style>
-          <a:lnRef idx="1">
-            <a:schemeClr val="accent1"/>
-          </a:lnRef>
-          <a:fillRef idx="3">
-            <a:schemeClr val="accent1"/>
-          </a:fillRef>
-          <a:effectRef idx="2">
-            <a:schemeClr val="accent1"/>
-          </a:effectRef>
-          <a:fontRef idx="minor">
-            <a:schemeClr val="lt1"/>
-          </a:fontRef>
-        </p:style>
-        <p:txBody>
-          <a:bodyPr rtlCol="0" anchor="ctr"/>
-          <a:lstStyle/>
-          <a:p>
-            <a:pPr algn="ctr"/>
-            <a:r>
-              <a:rPr sz="1800" b="1">
-                <a:solidFill>
-                  <a:srgbClr val="111111"/>
-                </a:solidFill>
-                <a:latin typeface="Poppins"/>
-              </a:rPr>
-              <a:t>3</a:t>
-            </a:r>
-          </a:p>
-        </p:txBody>
-      </p:sp>
-      <p:sp>
-        <p:nvSpPr>
-          <p:cNvPr id="15" name="TextBox 14"/>
-          <p:cNvSpPr txBox="1"/>
-          <p:nvPr/>
-        </p:nvSpPr>
-        <p:spPr>
-          <a:xfrm>
-            <a:off x="13133832" y="3575304"/>
-            <a:ext cx="3627120" cy="1005840"/>
-          </a:xfrm>
-          <a:prstGeom prst="rect">
-            <a:avLst/>
-          </a:prstGeom>
-          <a:noFill/>
-        </p:spPr>
-        <p:txBody>
-          <a:bodyPr wrap="square" lIns="0" rIns="0" tIns="0" bIns="0">
-            <a:spAutoFit/>
-          </a:bodyPr>
-          <a:lstStyle/>
-          <a:p>
-            <a:pPr algn="l">
-              <a:lnSpc>
-                <a:spcPct val="115000"/>
-              </a:lnSpc>
-              <a:spcAft>
-                <a:spcPts val="0"/>
-              </a:spcAft>
-            </a:pPr>
-            <a:r>
-              <a:rPr sz="2000" b="1">
-                <a:solidFill>
-                  <a:srgbClr val="111111"/>
-                </a:solidFill>
-                <a:latin typeface="Poppins"/>
-              </a:rPr>
-              <a:t>No-power jobs</a:t>
-            </a:r>
-          </a:p>
-        </p:txBody>
-      </p:sp>
-      <p:sp>
-        <p:nvSpPr>
-          <p:cNvPr id="16" name="TextBox 15"/>
-          <p:cNvSpPr txBox="1"/>
-          <p:nvPr/>
-        </p:nvSpPr>
-        <p:spPr>
-          <a:xfrm>
-            <a:off x="12347448" y="4846320"/>
-            <a:ext cx="4322064" cy="1097280"/>
-          </a:xfrm>
-          <a:prstGeom prst="rect">
-            <a:avLst/>
-          </a:prstGeom>
-          <a:noFill/>
-        </p:spPr>
-        <p:txBody>
-          <a:bodyPr wrap="square" lIns="0" rIns="0" tIns="0" bIns="0">
-            <a:spAutoFit/>
-          </a:bodyPr>
-          <a:lstStyle/>
-          <a:p>
-            <a:pPr algn="l">
-              <a:lnSpc>
-                <a:spcPct val="135000"/>
-              </a:lnSpc>
-              <a:spcAft>
-                <a:spcPts val="0"/>
-              </a:spcAft>
-            </a:pPr>
-            <a:r>
-              <a:rPr sz="1600" b="0">
-                <a:solidFill>
-                  <a:srgbClr val="5D6880"/>
-                </a:solidFill>
-                <a:latin typeface="Poppins"/>
-              </a:rPr>
               <a:t>Parked </a:t>
             </a:r>
             <a:r>
@@ -6468,7 +6275,7 @@
         </p:nvSpPr>
         <p:spPr>
           <a:xfrm>
-            <a:off x="1234440" y="6858000"/>
+            <a:off x="1234440" y="8275320"/>
             <a:ext cx="15819120" cy="1463040"/>
           </a:xfrm>
           <a:prstGeom prst="rect">
@@ -7440,7 +7247,7 @@
         <p:spPr>
           <a:xfrm>
             <a:off x="1234440" y="3154680"/>
-            <a:ext cx="3783330" cy="3931920"/>
+            <a:ext cx="3783330" cy="5349240"/>
           </a:xfrm>
           <a:prstGeom prst="roundRect">
             <a:avLst>
@@ -7485,7 +7292,7 @@
         </p:nvSpPr>
         <p:spPr>
           <a:xfrm>
-            <a:off x="1645920" y="3566160"/>
+            <a:off x="1645920" y="3611880"/>
             <a:ext cx="822960" cy="128016"/>
           </a:xfrm>
           <a:prstGeom prst="rect">
@@ -7527,8 +7334,8 @@
         </p:nvSpPr>
         <p:spPr>
           <a:xfrm>
-            <a:off x="1645920" y="3977639"/>
-            <a:ext cx="2960370" cy="640080"/>
+            <a:off x="1645920" y="4069080"/>
+            <a:ext cx="2960370" cy="822960"/>
           </a:xfrm>
           <a:prstGeom prst="rect">
             <a:avLst/>
@@ -7569,8 +7376,8 @@
         </p:nvSpPr>
         <p:spPr>
           <a:xfrm>
-            <a:off x="1645920" y="4800600"/>
-            <a:ext cx="2960370" cy="2011680"/>
+            <a:off x="1645920" y="5120640"/>
+            <a:ext cx="2960370" cy="3108960"/>
           </a:xfrm>
           <a:prstGeom prst="rect">
             <a:avLst/>
@@ -7592,7 +7399,7 @@
               </a:spcAft>
             </a:pPr>
             <a:r>
-              <a:rPr sz="1500" b="0">
+              <a:rPr sz="1600" b="0">
                 <a:solidFill>
                   <a:srgbClr val="5D6880"/>
                 </a:solidFill>
@@ -7601,7 +7408,7 @@
               <a:t>The shop runs </a:t>
             </a:r>
             <a:r>
-              <a:rPr sz="1500" b="1">
+              <a:rPr sz="1600" b="1">
                 <a:solidFill>
                   <a:srgbClr val="8A5D05"/>
                 </a:solidFill>
@@ -7610,7 +7417,7 @@
               <a:t>more than one</a:t>
             </a:r>
             <a:r>
-              <a:rPr sz="1500" b="0">
+              <a:rPr sz="1600" b="0">
                 <a:solidFill>
                   <a:srgbClr val="5D6880"/>
                 </a:solidFill>
@@ -7630,7 +7437,7 @@
         <p:spPr>
           <a:xfrm>
             <a:off x="5246370" y="3154680"/>
-            <a:ext cx="3783330" cy="3931920"/>
+            <a:ext cx="3783330" cy="5349240"/>
           </a:xfrm>
           <a:prstGeom prst="roundRect">
             <a:avLst>
@@ -7675,7 +7482,7 @@
         </p:nvSpPr>
         <p:spPr>
           <a:xfrm>
-            <a:off x="5657850" y="3566160"/>
+            <a:off x="5657850" y="3611880"/>
             <a:ext cx="822960" cy="128016"/>
           </a:xfrm>
           <a:prstGeom prst="rect">
@@ -7717,8 +7524,8 @@
         </p:nvSpPr>
         <p:spPr>
           <a:xfrm>
-            <a:off x="5657850" y="3977639"/>
-            <a:ext cx="2960370" cy="640080"/>
+            <a:off x="5657850" y="4069080"/>
+            <a:ext cx="2960370" cy="822960"/>
           </a:xfrm>
           <a:prstGeom prst="rect">
             <a:avLst/>
@@ -7759,8 +7566,8 @@
         </p:nvSpPr>
         <p:spPr>
           <a:xfrm>
-            <a:off x="5657850" y="4800600"/>
-            <a:ext cx="2960370" cy="2011680"/>
+            <a:off x="5657850" y="5120640"/>
+            <a:ext cx="2960370" cy="3108960"/>
           </a:xfrm>
           <a:prstGeom prst="rect">
             <a:avLst/>
@@ -7782,7 +7589,7 @@
               </a:spcAft>
             </a:pPr>
             <a:r>
-              <a:rPr sz="1500" b="0">
+              <a:rPr sz="1600" b="0">
                 <a:solidFill>
                   <a:srgbClr val="5D6880"/>
                 </a:solidFill>
@@ -7791,7 +7598,7 @@
               <a:t>A customer collects at 5pm. A job that </a:t>
             </a:r>
             <a:r>
-              <a:rPr sz="1500" b="1">
+              <a:rPr sz="1600" b="1">
                 <a:solidFill>
                   <a:srgbClr val="5D6880"/>
                 </a:solidFill>
@@ -7800,7 +7607,7 @@
               <a:t>cannot</a:t>
             </a:r>
             <a:r>
-              <a:rPr sz="1500" b="0">
+              <a:rPr sz="1600" b="0">
                 <a:solidFill>
                   <a:srgbClr val="5D6880"/>
                 </a:solidFill>
@@ -7820,7 +7627,7 @@
         <p:spPr>
           <a:xfrm>
             <a:off x="9258300" y="3154680"/>
-            <a:ext cx="3783330" cy="3931920"/>
+            <a:ext cx="3783330" cy="5349240"/>
           </a:xfrm>
           <a:prstGeom prst="roundRect">
             <a:avLst>
@@ -7865,7 +7672,7 @@
         </p:nvSpPr>
         <p:spPr>
           <a:xfrm>
-            <a:off x="9669780" y="3566160"/>
+            <a:off x="9669780" y="3611880"/>
             <a:ext cx="822960" cy="128016"/>
           </a:xfrm>
           <a:prstGeom prst="rect">
@@ -7907,8 +7714,8 @@
         </p:nvSpPr>
         <p:spPr>
           <a:xfrm>
-            <a:off x="9669780" y="3977639"/>
-            <a:ext cx="2960370" cy="640080"/>
+            <a:off x="9669780" y="4069080"/>
+            <a:ext cx="2960370" cy="822960"/>
           </a:xfrm>
           <a:prstGeom prst="rect">
             <a:avLst/>
@@ -7949,8 +7756,8 @@
         </p:nvSpPr>
         <p:spPr>
           <a:xfrm>
-            <a:off x="9669780" y="4800600"/>
-            <a:ext cx="2960370" cy="2011680"/>
+            <a:off x="9669780" y="5120640"/>
+            <a:ext cx="2960370" cy="3108960"/>
           </a:xfrm>
           <a:prstGeom prst="rect">
             <a:avLst/>
@@ -7972,7 +7779,7 @@
               </a:spcAft>
             </a:pPr>
             <a:r>
-              <a:rPr sz="1500" b="0">
+              <a:rPr sz="1600" b="0">
                 <a:solidFill>
                   <a:srgbClr val="5D6880"/>
                 </a:solidFill>
@@ -7981,7 +7788,7 @@
               <a:t>Mark a job urgent and it takes the </a:t>
             </a:r>
             <a:r>
-              <a:rPr sz="1500" b="1">
+              <a:rPr sz="1600" b="1">
                 <a:solidFill>
                   <a:srgbClr val="8A5D05"/>
                 </a:solidFill>
@@ -7990,7 +7797,7 @@
               <a:t>front of the day</a:t>
             </a:r>
             <a:r>
-              <a:rPr sz="1500" b="0">
+              <a:rPr sz="1600" b="0">
                 <a:solidFill>
                   <a:srgbClr val="5D6880"/>
                 </a:solidFill>
@@ -8010,7 +7817,7 @@
         <p:spPr>
           <a:xfrm>
             <a:off x="13270230" y="3154680"/>
-            <a:ext cx="3783330" cy="3931920"/>
+            <a:ext cx="3783330" cy="5349240"/>
           </a:xfrm>
           <a:prstGeom prst="roundRect">
             <a:avLst>
@@ -8055,7 +7862,7 @@
         </p:nvSpPr>
         <p:spPr>
           <a:xfrm>
-            <a:off x="13681710" y="3566160"/>
+            <a:off x="13681710" y="3611880"/>
             <a:ext cx="822960" cy="128016"/>
           </a:xfrm>
           <a:prstGeom prst="rect">
@@ -8097,8 +7904,8 @@
         </p:nvSpPr>
         <p:spPr>
           <a:xfrm>
-            <a:off x="13681710" y="3977639"/>
-            <a:ext cx="2960370" cy="640080"/>
+            <a:off x="13681710" y="4069080"/>
+            <a:ext cx="2960370" cy="822960"/>
           </a:xfrm>
           <a:prstGeom prst="rect">
             <a:avLst/>
@@ -8139,8 +7946,8 @@
         </p:nvSpPr>
         <p:spPr>
           <a:xfrm>
-            <a:off x="13681710" y="4800600"/>
-            <a:ext cx="2960370" cy="2011680"/>
+            <a:off x="13681710" y="5120640"/>
+            <a:ext cx="2960370" cy="3108960"/>
           </a:xfrm>
           <a:prstGeom prst="rect">
             <a:avLst/>
@@ -8162,7 +7969,7 @@
               </a:spcAft>
             </a:pPr>
             <a:r>
-              <a:rPr sz="1500" b="0">
+              <a:rPr sz="1600" b="0">
                 <a:solidFill>
                   <a:srgbClr val="5D6880"/>
                 </a:solidFill>
@@ -8171,7 +7978,7 @@
               <a:t>Diesel is bought by the litre. Cap the generator minutes and the planner </a:t>
             </a:r>
             <a:r>
-              <a:rPr sz="1500" b="1">
+              <a:rPr sz="1600" b="1">
                 <a:solidFill>
                   <a:srgbClr val="8A5D05"/>
                 </a:solidFill>
@@ -8180,7 +7987,7 @@
               <a:t>will not exceed it</a:t>
             </a:r>
             <a:r>
-              <a:rPr sz="1500" b="0">
+              <a:rPr sz="1600" b="0">
                 <a:solidFill>
                   <a:srgbClr val="5D6880"/>
                 </a:solidFill>
@@ -8343,9 +8150,33 @@
           <a:p/>
         </p:txBody>
       </p:sp>
-      <p:sp>
-        <p:nvSpPr>
-          <p:cNvPr id="5" name="TextBox 4"/>
+      <p:pic>
+        <p:nvPicPr>
+          <p:cNvPr id="5" name="Picture 4" descr="mark-tick.png"/>
+          <p:cNvPicPr>
+            <a:picLocks noChangeAspect="1"/>
+          </p:cNvPicPr>
+          <p:nvPr/>
+        </p:nvPicPr>
+        <p:blipFill>
+          <a:blip r:embed="rId2"/>
+          <a:stretch>
+            <a:fillRect/>
+          </a:stretch>
+        </p:blipFill>
+        <p:spPr>
+          <a:xfrm>
+            <a:off x="15681960" y="8641080"/>
+            <a:ext cx="1371600" cy="1371600"/>
+          </a:xfrm>
+          <a:prstGeom prst="rect">
+            <a:avLst/>
+          </a:prstGeom>
+        </p:spPr>
+      </p:pic>
+      <p:sp>
+        <p:nvSpPr>
+          <p:cNvPr id="6" name="TextBox 5"/>
           <p:cNvSpPr txBox="1"/>
           <p:nvPr/>
         </p:nvSpPr>
@@ -8535,24 +8366,70 @@
           </a:p>
         </p:txBody>
       </p:sp>
+      <p:sp>
+        <p:nvSpPr>
+          <p:cNvPr id="7" name="Rounded Rectangle 6"/>
+          <p:cNvSpPr/>
+          <p:nvPr/>
+        </p:nvSpPr>
+        <p:spPr>
+          <a:xfrm>
+            <a:off x="10561320" y="3017520"/>
+            <a:ext cx="6492240" cy="5394960"/>
+          </a:xfrm>
+          <a:prstGeom prst="roundRect">
+            <a:avLst>
+              <a:gd name="adj" fmla="val 8000"/>
+            </a:avLst>
+          </a:prstGeom>
+          <a:solidFill>
+            <a:srgbClr val="FFFFFF"/>
+          </a:solidFill>
+          <a:ln w="12700">
+            <a:solidFill>
+              <a:srgbClr val="E8E3D6"/>
+            </a:solidFill>
+          </a:ln>
+          <a:effectLst/>
+        </p:spPr>
+        <p:style>
+          <a:lnRef idx="1">
+            <a:schemeClr val="accent1"/>
+          </a:lnRef>
+          <a:fillRef idx="3">
+            <a:schemeClr val="accent1"/>
+          </a:fillRef>
+          <a:effectRef idx="2">
+            <a:schemeClr val="accent1"/>
+          </a:effectRef>
+          <a:fontRef idx="minor">
+            <a:schemeClr val="lt1"/>
+          </a:fontRef>
+        </p:style>
+        <p:txBody>
+          <a:bodyPr rtlCol="0" anchor="ctr"/>
+          <a:lstStyle/>
+          <a:p/>
+        </p:txBody>
+      </p:sp>
       <p:pic>
         <p:nvPicPr>
-          <p:cNvPr id="6" name="Picture 5" descr="chart-donut.png"/>
+          <p:cNvPr id="8" name="Picture 7" descr="chart-donut.png"/>
           <p:cNvPicPr>
             <a:picLocks noChangeAspect="1"/>
           </p:cNvPicPr>
           <p:nvPr/>
         </p:nvPicPr>
         <p:blipFill>
-          <a:blip r:embed="rId2"/>
+          <a:blip r:embed="rId3"/>
           <a:stretch>
             <a:fillRect/>
           </a:stretch>
         </p:blipFill>
         <p:spPr>
           <a:xfrm>
-            <a:off x="10744200" y="3017520"/>
-            <a:ext cx="4572000" cy="4572000"/>
+            <a:off x="12070080" y="3291840"/>
+            <a:ext cx="3840480" cy="3840480"/>
           </a:xfrm>
           <a:prstGeom prst="rect">
             <a:avLst/>
@@ -8561,14 +8438,14 @@
       </p:pic>
       <p:sp>
         <p:nvSpPr>
-          <p:cNvPr id="7" name="TextBox 6"/>
+          <p:cNvPr id="9" name="TextBox 8"/>
           <p:cNvSpPr txBox="1"/>
           <p:nvPr/>
         </p:nvSpPr>
         <p:spPr>
           <a:xfrm>
-            <a:off x="10744200" y="7772400"/>
-            <a:ext cx="6035040" cy="731520"/>
+            <a:off x="11018520" y="7360920"/>
+            <a:ext cx="5577840" cy="914400"/>
           </a:xfrm>
           <a:prstGeom prst="rect">
             <a:avLst/>
@@ -8727,8 +8604,8 @@
         </p:blipFill>
         <p:spPr>
           <a:xfrm>
-            <a:off x="1234440" y="3017520"/>
-            <a:ext cx="15819120" cy="6049872"/>
+            <a:off x="1234440" y="2880360"/>
+            <a:ext cx="15819120" cy="3934288"/>
           </a:xfrm>
           <a:prstGeom prst="rect">
             <a:avLst/>
@@ -8743,7 +8620,7 @@
         </p:nvSpPr>
         <p:spPr>
           <a:xfrm>
-            <a:off x="1234440" y="8138160"/>
+            <a:off x="1234440" y="7226128"/>
             <a:ext cx="15819120" cy="1280160"/>
           </a:xfrm>
           <a:prstGeom prst="rect">

</xml_diff>